<commit_message>
Paparan direksi: hapus hasil uji coba, halaman 3 jadi pengguna, kesiapan, dan usulan
Co-Authored-By: Claude Opus 5.5 <noreply@anthropic.com>
Claude-Session: https://claude.ai/code/session_01JEY5regGSA4jYBqyTUCMow
</commit_message>
<xml_diff>
--- a/docs/PID_POS_Paparan_Direksi.pptx
+++ b/docs/PID_POS_Paparan_Direksi.pptx
@@ -592,7 +592,7 @@
           <a:p>
             <a:r>
               <a:rPr lang="en-US" dirty="0"/>
-              <a:t>Ada sembilan tahap. Jalur atas selalu dijalani. Jalur bawah, PUR, PO, dan GRPO, hanya dijalani bila stok DC tidak cukup. Label hijau menunjukkan dokumen SAP yang terbentuk setelah tahap itu disetujui. Bila semua barang ada di stok DC, tahap PUR, PO, dan GRPO dilewati. Bila sebagian harus dibeli, seperti contoh ini, semua tahap dijalani, dan Inventory Transfer menunggu GRPO lalu dikirim sekali, tetap satu dokumen per dek.</a:t>
+              <a:t>Satu permintaan dari kapal bisa dilacak sampai barangnya terjual. Jalur atas selalu dijalani: kapal memesan, Sales Order disetujui, DC memilah stok, barang dikirim ke dek, diterima, lalu dijual di kasir dan masuk SAP sebagai Delivery Order. Jalur bawah, PUR, PO, dan GRPO, hanya dijalani bila stok DC tidak cukup. Label hijau menunjukkan dokumen SAP yang dibuat otomatis setelah tiap tahap disetujui.</a:t>
             </a:r>
             <a:endParaRPr lang="en-US" dirty="0"/>
           </a:p>
@@ -680,7 +680,7 @@
           <a:p>
             <a:r>
               <a:rPr lang="en-US" dirty="0"/>
-              <a:t>Uji coba menyeluruh dilakukan pada 22 Oktober 2026 di server dev dengan SAP DB_TEST. Satu permintaan dari KM Awu dijalankan lengkap melewati sembilan tahap oleh tujuh peran, dan semua dokumen terbentuk di SAP: Sales Order, Purchase Request, Purchase Order, GRPO, Inventory Transfer, dan Delivery Order. Satu temuan hak akses sudah diperbaiki; satu masih terbuka, yaitu kode customer per dek di SAP. Materi sosialisasi sudah siap: manual book per peran, sembilan video tutorial, dan empat video pendek. Usulan langkah berikutnya: lengkapi kode customer per dek, pilot di satu kapal dengan SAP produksi, lalu sosialisasi ke seluruh peran.</a:t>
+              <a:t>PID POS dipakai di tiga tempat: di kapal oleh kepala toko dan kasir, di DC oleh admin gudang, dan di kantor pusat oleh para penyetuju dan admin purchase. Materi sosialisasi sudah siap: manual book per peran, sembilan video tutorial, dan empat video pendek. Usulan langkah berikutnya: menyiapkan akun dan level approval untuk setiap peran, menjalankan pilot di satu kapal dengan SAP produksi, lalu sosialisasi ke seluruh peran.</a:t>
             </a:r>
             <a:endParaRPr lang="en-US" dirty="0"/>
           </a:p>
@@ -869,7 +869,7 @@
                   <a:schemeClr val="accent5"/>
                 </a:solidFill>
               </a:rPr>
-              <a:t>PID POS · Paparan direksi · Data uji coba 22-10-2026 (SAP DB_TEST)</a:t>
+              <a:t>PID POS · Paparan direksi</a:t>
             </a:r>
             <a:endParaRPr lang="en-US" sz="1000" dirty="0"/>
           </a:p>
@@ -3670,7 +3670,7 @@
                   <a:srgbClr val="FF6B1A"/>
                 </a:solidFill>
               </a:rPr>
-              <a:t>Contoh: </a:t>
+              <a:t>Contohnya: </a:t>
             </a:r>
             <a:pPr indent="0" marL="0">
               <a:buNone/>
@@ -3681,7 +3681,7 @@
                   <a:srgbClr val="1B2437"/>
                 </a:solidFill>
               </a:rPr>
-              <a:t>PERMINTAAN-AWU/2610/0008 · KM Awu · AQUA 6 pcs ke Dek 3 dari stok DC · Teh Pucuk 24 pcs ke Dek 7 dibeli lewat PUR dan PO</a:t>
+              <a:t>barang yang ada di gudang langsung dikirim ke dek; yang kurang dibeli dulu lewat PUR dan PO, lalu dikirim bersama.</a:t>
             </a:r>
             <a:endParaRPr lang="en-US" sz="1400" dirty="0"/>
           </a:p>
@@ -3789,7 +3789,7 @@
                   <a:schemeClr val="tx2"/>
                 </a:solidFill>
               </a:rPr>
-              <a:t>Uji coba berhasil, siap ke tahap berikutnya</a:t>
+              <a:t>Siap diterapkan di kapal, DC, dan kantor pusat</a:t>
             </a:r>
             <a:endParaRPr lang="en-US" sz="3400" dirty="0"/>
           </a:p>
@@ -3797,7 +3797,7 @@
       </p:sp>
       <p:sp>
         <p:nvSpPr>
-          <p:cNvPr id="3" name="Hasil uji coba"/>
+          <p:cNvPr id="3" name="Pengguna"/>
           <p:cNvSpPr/>
           <p:nvPr/>
         </p:nvSpPr>
@@ -3852,7 +3852,7 @@
                   <a:srgbClr val="1F3B7A"/>
                 </a:solidFill>
               </a:rPr>
-              <a:t>Hasil uji coba 22-10-2026</a:t>
+              <a:t>Pengguna PID POS</a:t>
             </a:r>
             <a:endParaRPr lang="en-US" sz="1800" dirty="0"/>
           </a:p>
@@ -3867,17 +3867,19 @@
         <p:spPr>
           <a:xfrm>
             <a:off x="685800" y="1828800"/>
-            <a:ext cx="384048" cy="384048"/>
-          </a:xfrm>
-          <a:prstGeom prst="ellipse">
-            <a:avLst/>
-          </a:prstGeom>
-          <a:solidFill>
-            <a:srgbClr val="3A7D3A"/>
+            <a:ext cx="1463040" cy="384048"/>
+          </a:xfrm>
+          <a:prstGeom prst="roundRect">
+            <a:avLst>
+              <a:gd name="adj" fmla="val 19048"/>
+            </a:avLst>
+          </a:prstGeom>
+          <a:solidFill>
+            <a:srgbClr val="0F766E"/>
           </a:solidFill>
           <a:ln>
             <a:solidFill>
-              <a:srgbClr val="3A7D3A"/>
+              <a:srgbClr val="0F766E"/>
             </a:solidFill>
           </a:ln>
         </p:spPr>
@@ -3889,14 +3891,14 @@
               <a:buNone/>
             </a:pPr>
             <a:r>
-              <a:rPr lang="en-US" sz="1400" b="1" dirty="0">
+              <a:rPr lang="en-US" sz="1300" b="1" dirty="0">
                 <a:solidFill>
                   <a:srgbClr val="FFFFFF"/>
                 </a:solidFill>
               </a:rPr>
-              <a:t>✓</a:t>
-            </a:r>
-            <a:endParaRPr lang="en-US" sz="1400" dirty="0"/>
+              <a:t>Kapal</a:t>
+            </a:r>
+            <a:endParaRPr lang="en-US" sz="1300" dirty="0"/>
           </a:p>
         </p:txBody>
       </p:sp>
@@ -3908,31 +3910,39 @@
         </p:nvSpPr>
         <p:spPr>
           <a:xfrm>
-            <a:off x="1234440" y="1773936"/>
-            <a:ext cx="4526280" cy="512064"/>
-          </a:xfrm>
-          <a:prstGeom prst="rect">
-            <a:avLst/>
-          </a:prstGeom>
-          <a:noFill/>
-          <a:ln/>
+            <a:off x="2286000" y="1828800"/>
+            <a:ext cx="1691640" cy="384048"/>
+          </a:xfrm>
+          <a:prstGeom prst="roundRect">
+            <a:avLst>
+              <a:gd name="adj" fmla="val 19048"/>
+            </a:avLst>
+          </a:prstGeom>
+          <a:solidFill>
+            <a:srgbClr val="FFFFFF"/>
+          </a:solidFill>
+          <a:ln w="12700">
+            <a:solidFill>
+              <a:srgbClr val="D5DEEC"/>
+            </a:solidFill>
+          </a:ln>
         </p:spPr>
         <p:txBody>
           <a:bodyPr wrap="square" lIns="0" tIns="0" rIns="0" bIns="0" rtlCol="0" anchor="ctr"/>
           <a:lstStyle/>
           <a:p>
-            <a:pPr indent="0" marL="0">
-              <a:buNone/>
-            </a:pPr>
-            <a:r>
-              <a:rPr lang="en-US" sz="1400" dirty="0">
+            <a:pPr algn="ctr" indent="0" marL="0">
+              <a:buNone/>
+            </a:pPr>
+            <a:r>
+              <a:rPr lang="en-US" sz="1200" dirty="0">
                 <a:solidFill>
                   <a:srgbClr val="1B2437"/>
                 </a:solidFill>
               </a:rPr>
-              <a:t>Satu permintaan dijalankan penuh, 9 tahap, oleh 7 peran</a:t>
-            </a:r>
-            <a:endParaRPr lang="en-US" sz="1400" dirty="0"/>
+              <a:t>Kepala Toko / Admin Kapal</a:t>
+            </a:r>
+            <a:endParaRPr lang="en-US" sz="1200" dirty="0"/>
           </a:p>
         </p:txBody>
       </p:sp>
@@ -3944,18 +3954,64 @@
         </p:nvSpPr>
         <p:spPr>
           <a:xfrm>
-            <a:off x="685800" y="2450592"/>
-            <a:ext cx="384048" cy="384048"/>
-          </a:xfrm>
-          <a:prstGeom prst="ellipse">
-            <a:avLst/>
-          </a:prstGeom>
-          <a:solidFill>
-            <a:srgbClr val="3A7D3A"/>
+            <a:off x="4069080" y="1828800"/>
+            <a:ext cx="1691640" cy="384048"/>
+          </a:xfrm>
+          <a:prstGeom prst="roundRect">
+            <a:avLst>
+              <a:gd name="adj" fmla="val 19048"/>
+            </a:avLst>
+          </a:prstGeom>
+          <a:solidFill>
+            <a:srgbClr val="FFFFFF"/>
+          </a:solidFill>
+          <a:ln w="12700">
+            <a:solidFill>
+              <a:srgbClr val="D5DEEC"/>
+            </a:solidFill>
+          </a:ln>
+        </p:spPr>
+        <p:txBody>
+          <a:bodyPr wrap="square" lIns="0" tIns="0" rIns="0" bIns="0" rtlCol="0" anchor="ctr"/>
+          <a:lstStyle/>
+          <a:p>
+            <a:pPr algn="ctr" indent="0" marL="0">
+              <a:buNone/>
+            </a:pPr>
+            <a:r>
+              <a:rPr lang="en-US" sz="1200" dirty="0">
+                <a:solidFill>
+                  <a:srgbClr val="1B2437"/>
+                </a:solidFill>
+              </a:rPr>
+              <a:t>Kasir (per dek)</a:t>
+            </a:r>
+            <a:endParaRPr lang="en-US" sz="1200" dirty="0"/>
+          </a:p>
+        </p:txBody>
+      </p:sp>
+      <p:sp>
+        <p:nvSpPr>
+          <p:cNvPr id="8" name="Text 6"/>
+          <p:cNvSpPr txBox="1"/>
+          <p:nvPr/>
+        </p:nvSpPr>
+        <p:spPr>
+          <a:xfrm>
+            <a:off x="685800" y="2487168"/>
+            <a:ext cx="1463040" cy="384048"/>
+          </a:xfrm>
+          <a:prstGeom prst="roundRect">
+            <a:avLst>
+              <a:gd name="adj" fmla="val 19048"/>
+            </a:avLst>
+          </a:prstGeom>
+          <a:solidFill>
+            <a:srgbClr val="EA580C"/>
           </a:solidFill>
           <a:ln>
             <a:solidFill>
-              <a:srgbClr val="3A7D3A"/>
+              <a:srgbClr val="EA580C"/>
             </a:solidFill>
           </a:ln>
         </p:spPr>
@@ -3967,73 +4023,83 @@
               <a:buNone/>
             </a:pPr>
             <a:r>
-              <a:rPr lang="en-US" sz="1400" b="1" dirty="0">
+              <a:rPr lang="en-US" sz="1300" b="1" dirty="0">
                 <a:solidFill>
                   <a:srgbClr val="FFFFFF"/>
                 </a:solidFill>
               </a:rPr>
-              <a:t>✓</a:t>
-            </a:r>
-            <a:endParaRPr lang="en-US" sz="1400" dirty="0"/>
-          </a:p>
-        </p:txBody>
-      </p:sp>
-      <p:sp>
-        <p:nvSpPr>
-          <p:cNvPr id="8" name="Text 6"/>
-          <p:cNvSpPr txBox="1"/>
-          <p:nvPr/>
-        </p:nvSpPr>
-        <p:spPr>
-          <a:xfrm>
-            <a:off x="1234440" y="2395728"/>
-            <a:ext cx="4526280" cy="512064"/>
-          </a:xfrm>
-          <a:prstGeom prst="rect">
-            <a:avLst/>
-          </a:prstGeom>
-          <a:noFill/>
-          <a:ln/>
+              <a:t>DC / Gudang</a:t>
+            </a:r>
+            <a:endParaRPr lang="en-US" sz="1300" dirty="0"/>
+          </a:p>
+        </p:txBody>
+      </p:sp>
+      <p:sp>
+        <p:nvSpPr>
+          <p:cNvPr id="9" name="Text 7"/>
+          <p:cNvSpPr txBox="1"/>
+          <p:nvPr/>
+        </p:nvSpPr>
+        <p:spPr>
+          <a:xfrm>
+            <a:off x="2286000" y="2487168"/>
+            <a:ext cx="1691640" cy="384048"/>
+          </a:xfrm>
+          <a:prstGeom prst="roundRect">
+            <a:avLst>
+              <a:gd name="adj" fmla="val 19048"/>
+            </a:avLst>
+          </a:prstGeom>
+          <a:solidFill>
+            <a:srgbClr val="FFFFFF"/>
+          </a:solidFill>
+          <a:ln w="12700">
+            <a:solidFill>
+              <a:srgbClr val="D5DEEC"/>
+            </a:solidFill>
+          </a:ln>
         </p:spPr>
         <p:txBody>
           <a:bodyPr wrap="square" lIns="0" tIns="0" rIns="0" bIns="0" rtlCol="0" anchor="ctr"/>
           <a:lstStyle/>
           <a:p>
-            <a:pPr indent="0" marL="0">
-              <a:buNone/>
-            </a:pPr>
-            <a:r>
-              <a:rPr lang="en-US" sz="1400" dirty="0">
+            <a:pPr algn="ctr" indent="0" marL="0">
+              <a:buNone/>
+            </a:pPr>
+            <a:r>
+              <a:rPr lang="en-US" sz="1200" dirty="0">
                 <a:solidFill>
                   <a:srgbClr val="1B2437"/>
                 </a:solidFill>
               </a:rPr>
-              <a:t>Semua dokumen terbentuk di SAP: SO, PUR, PO, GRPO, Inventory Transfer, DO</a:t>
-            </a:r>
-            <a:endParaRPr lang="en-US" sz="1400" dirty="0"/>
-          </a:p>
-        </p:txBody>
-      </p:sp>
-      <p:sp>
-        <p:nvSpPr>
-          <p:cNvPr id="9" name="Text 7"/>
-          <p:cNvSpPr txBox="1"/>
-          <p:nvPr/>
-        </p:nvSpPr>
-        <p:spPr>
-          <a:xfrm>
-            <a:off x="685800" y="3072384"/>
-            <a:ext cx="384048" cy="384048"/>
-          </a:xfrm>
-          <a:prstGeom prst="ellipse">
-            <a:avLst/>
-          </a:prstGeom>
-          <a:solidFill>
-            <a:srgbClr val="3A7D3A"/>
+              <a:t>Admin DC</a:t>
+            </a:r>
+            <a:endParaRPr lang="en-US" sz="1200" dirty="0"/>
+          </a:p>
+        </p:txBody>
+      </p:sp>
+      <p:sp>
+        <p:nvSpPr>
+          <p:cNvPr id="10" name="Text 8"/>
+          <p:cNvSpPr txBox="1"/>
+          <p:nvPr/>
+        </p:nvSpPr>
+        <p:spPr>
+          <a:xfrm>
+            <a:off x="685800" y="3145536"/>
+            <a:ext cx="1463040" cy="384048"/>
+          </a:xfrm>
+          <a:prstGeom prst="roundRect">
+            <a:avLst>
+              <a:gd name="adj" fmla="val 19048"/>
+            </a:avLst>
+          </a:prstGeom>
+          <a:solidFill>
+            <a:srgbClr val="2563EB"/>
           </a:solidFill>
           <a:ln>
             <a:solidFill>
-              <a:srgbClr val="3A7D3A"/>
+              <a:srgbClr val="2563EB"/>
             </a:solidFill>
           </a:ln>
         </p:spPr>
@@ -4045,50 +4111,14 @@
               <a:buNone/>
             </a:pPr>
             <a:r>
-              <a:rPr lang="en-US" sz="1400" b="1" dirty="0">
+              <a:rPr lang="en-US" sz="1300" b="1" dirty="0">
                 <a:solidFill>
                   <a:srgbClr val="FFFFFF"/>
                 </a:solidFill>
               </a:rPr>
-              <a:t>✓</a:t>
-            </a:r>
-            <a:endParaRPr lang="en-US" sz="1400" dirty="0"/>
-          </a:p>
-        </p:txBody>
-      </p:sp>
-      <p:sp>
-        <p:nvSpPr>
-          <p:cNvPr id="10" name="Text 8"/>
-          <p:cNvSpPr txBox="1"/>
-          <p:nvPr/>
-        </p:nvSpPr>
-        <p:spPr>
-          <a:xfrm>
-            <a:off x="1234440" y="3017520"/>
-            <a:ext cx="4526280" cy="512064"/>
-          </a:xfrm>
-          <a:prstGeom prst="rect">
-            <a:avLst/>
-          </a:prstGeom>
-          <a:noFill/>
-          <a:ln/>
-        </p:spPr>
-        <p:txBody>
-          <a:bodyPr wrap="square" lIns="0" tIns="0" rIns="0" bIns="0" rtlCol="0" anchor="ctr"/>
-          <a:lstStyle/>
-          <a:p>
-            <a:pPr indent="0" marL="0">
-              <a:buNone/>
-            </a:pPr>
-            <a:r>
-              <a:rPr lang="en-US" sz="1400" dirty="0">
-                <a:solidFill>
-                  <a:srgbClr val="1B2437"/>
-                </a:solidFill>
-              </a:rPr>
-              <a:t>Temuan hak akses penyetuju sudah diperbaiki (rilis 20261022_2202)</a:t>
-            </a:r>
-            <a:endParaRPr lang="en-US" sz="1400" dirty="0"/>
+              <a:t>Kantor pusat</a:t>
+            </a:r>
+            <a:endParaRPr lang="en-US" sz="1300" dirty="0"/>
           </a:p>
         </p:txBody>
       </p:sp>
@@ -4100,18 +4130,20 @@
         </p:nvSpPr>
         <p:spPr>
           <a:xfrm>
-            <a:off x="685800" y="3694176"/>
-            <a:ext cx="384048" cy="384048"/>
-          </a:xfrm>
-          <a:prstGeom prst="ellipse">
-            <a:avLst/>
-          </a:prstGeom>
-          <a:solidFill>
-            <a:srgbClr val="FF6B1A"/>
-          </a:solidFill>
-          <a:ln>
+            <a:off x="2286000" y="3145536"/>
+            <a:ext cx="1691640" cy="384048"/>
+          </a:xfrm>
+          <a:prstGeom prst="roundRect">
+            <a:avLst>
+              <a:gd name="adj" fmla="val 19048"/>
+            </a:avLst>
+          </a:prstGeom>
+          <a:solidFill>
+            <a:srgbClr val="FFFFFF"/>
+          </a:solidFill>
+          <a:ln w="12700">
             <a:solidFill>
-              <a:srgbClr val="FF6B1A"/>
+              <a:srgbClr val="D5DEEC"/>
             </a:solidFill>
           </a:ln>
         </p:spPr>
@@ -4123,14 +4155,14 @@
               <a:buNone/>
             </a:pPr>
             <a:r>
-              <a:rPr lang="en-US" sz="1400" b="1" dirty="0">
-                <a:solidFill>
-                  <a:srgbClr val="FFFFFF"/>
-                </a:solidFill>
-              </a:rPr>
-              <a:t>!</a:t>
-            </a:r>
-            <a:endParaRPr lang="en-US" sz="1400" dirty="0"/>
+              <a:rPr lang="en-US" sz="1200" dirty="0">
+                <a:solidFill>
+                  <a:srgbClr val="1B2437"/>
+                </a:solidFill>
+              </a:rPr>
+              <a:t>Approve SO (P2)</a:t>
+            </a:r>
+            <a:endParaRPr lang="en-US" sz="1200" dirty="0"/>
           </a:p>
         </p:txBody>
       </p:sp>
@@ -4142,37 +4174,133 @@
         </p:nvSpPr>
         <p:spPr>
           <a:xfrm>
-            <a:off x="1234440" y="3639312"/>
-            <a:ext cx="4526280" cy="512064"/>
-          </a:xfrm>
-          <a:prstGeom prst="rect">
-            <a:avLst/>
-          </a:prstGeom>
-          <a:noFill/>
-          <a:ln/>
+            <a:off x="4069080" y="3145536"/>
+            <a:ext cx="1691640" cy="384048"/>
+          </a:xfrm>
+          <a:prstGeom prst="roundRect">
+            <a:avLst>
+              <a:gd name="adj" fmla="val 19048"/>
+            </a:avLst>
+          </a:prstGeom>
+          <a:solidFill>
+            <a:srgbClr val="FFFFFF"/>
+          </a:solidFill>
+          <a:ln w="12700">
+            <a:solidFill>
+              <a:srgbClr val="D5DEEC"/>
+            </a:solidFill>
+          </a:ln>
         </p:spPr>
         <p:txBody>
           <a:bodyPr wrap="square" lIns="0" tIns="0" rIns="0" bIns="0" rtlCol="0" anchor="ctr"/>
           <a:lstStyle/>
           <a:p>
-            <a:pPr indent="0" marL="0">
-              <a:buNone/>
-            </a:pPr>
-            <a:r>
-              <a:rPr lang="en-US" sz="1400" dirty="0">
+            <a:pPr algn="ctr" indent="0" marL="0">
+              <a:buNone/>
+            </a:pPr>
+            <a:r>
+              <a:rPr lang="en-US" sz="1200" dirty="0">
                 <a:solidFill>
                   <a:srgbClr val="1B2437"/>
                 </a:solidFill>
               </a:rPr>
-              <a:t>Terbuka: Sales Order masih memakai customer umum; kode customer per dek perlu diisi</a:t>
-            </a:r>
-            <a:endParaRPr lang="en-US" sz="1400" dirty="0"/>
-          </a:p>
-        </p:txBody>
-      </p:sp>
-      <p:sp>
-        <p:nvSpPr>
-          <p:cNvPr id="13" name="Materi sosialisasi"/>
+              <a:t>Approve PUR</a:t>
+            </a:r>
+            <a:endParaRPr lang="en-US" sz="1200" dirty="0"/>
+          </a:p>
+        </p:txBody>
+      </p:sp>
+      <p:sp>
+        <p:nvSpPr>
+          <p:cNvPr id="13" name="Text 11"/>
+          <p:cNvSpPr txBox="1"/>
+          <p:nvPr/>
+        </p:nvSpPr>
+        <p:spPr>
+          <a:xfrm>
+            <a:off x="2286000" y="3602736"/>
+            <a:ext cx="1691640" cy="384048"/>
+          </a:xfrm>
+          <a:prstGeom prst="roundRect">
+            <a:avLst>
+              <a:gd name="adj" fmla="val 19048"/>
+            </a:avLst>
+          </a:prstGeom>
+          <a:solidFill>
+            <a:srgbClr val="FFFFFF"/>
+          </a:solidFill>
+          <a:ln w="12700">
+            <a:solidFill>
+              <a:srgbClr val="D5DEEC"/>
+            </a:solidFill>
+          </a:ln>
+        </p:spPr>
+        <p:txBody>
+          <a:bodyPr wrap="square" lIns="0" tIns="0" rIns="0" bIns="0" rtlCol="0" anchor="ctr"/>
+          <a:lstStyle/>
+          <a:p>
+            <a:pPr algn="ctr" indent="0" marL="0">
+              <a:buNone/>
+            </a:pPr>
+            <a:r>
+              <a:rPr lang="en-US" sz="1200" dirty="0">
+                <a:solidFill>
+                  <a:srgbClr val="1B2437"/>
+                </a:solidFill>
+              </a:rPr>
+              <a:t>Admin Purchase</a:t>
+            </a:r>
+            <a:endParaRPr lang="en-US" sz="1200" dirty="0"/>
+          </a:p>
+        </p:txBody>
+      </p:sp>
+      <p:sp>
+        <p:nvSpPr>
+          <p:cNvPr id="14" name="Text 12"/>
+          <p:cNvSpPr txBox="1"/>
+          <p:nvPr/>
+        </p:nvSpPr>
+        <p:spPr>
+          <a:xfrm>
+            <a:off x="4069080" y="3602736"/>
+            <a:ext cx="1691640" cy="384048"/>
+          </a:xfrm>
+          <a:prstGeom prst="roundRect">
+            <a:avLst>
+              <a:gd name="adj" fmla="val 19048"/>
+            </a:avLst>
+          </a:prstGeom>
+          <a:solidFill>
+            <a:srgbClr val="FFFFFF"/>
+          </a:solidFill>
+          <a:ln w="12700">
+            <a:solidFill>
+              <a:srgbClr val="D5DEEC"/>
+            </a:solidFill>
+          </a:ln>
+        </p:spPr>
+        <p:txBody>
+          <a:bodyPr wrap="square" lIns="0" tIns="0" rIns="0" bIns="0" rtlCol="0" anchor="ctr"/>
+          <a:lstStyle/>
+          <a:p>
+            <a:pPr algn="ctr" indent="0" marL="0">
+              <a:buNone/>
+            </a:pPr>
+            <a:r>
+              <a:rPr lang="en-US" sz="1200" dirty="0">
+                <a:solidFill>
+                  <a:srgbClr val="1B2437"/>
+                </a:solidFill>
+              </a:rPr>
+              <a:t>Approve PO</a:t>
+            </a:r>
+            <a:endParaRPr lang="en-US" sz="1200" dirty="0"/>
+          </a:p>
+        </p:txBody>
+      </p:sp>
+      <p:sp>
+        <p:nvSpPr>
+          <p:cNvPr id="15" name="Materi sosialisasi"/>
           <p:cNvSpPr/>
           <p:nvPr/>
         </p:nvSpPr>
@@ -4199,7 +4327,7 @@
       </p:sp>
       <p:sp>
         <p:nvSpPr>
-          <p:cNvPr id="14" name="Text 12"/>
+          <p:cNvPr id="16" name="Text 14"/>
           <p:cNvSpPr txBox="1"/>
           <p:nvPr/>
         </p:nvSpPr>
@@ -4235,7 +4363,7 @@
       </p:sp>
       <p:sp>
         <p:nvSpPr>
-          <p:cNvPr id="15" name="Text 13"/>
+          <p:cNvPr id="17" name="Text 15"/>
           <p:cNvSpPr txBox="1"/>
           <p:nvPr/>
         </p:nvSpPr>
@@ -4271,7 +4399,7 @@
       </p:sp>
       <p:sp>
         <p:nvSpPr>
-          <p:cNvPr id="16" name="Text 14"/>
+          <p:cNvPr id="18" name="Text 16"/>
           <p:cNvSpPr txBox="1"/>
           <p:nvPr/>
         </p:nvSpPr>
@@ -4321,7 +4449,7 @@
       </p:sp>
       <p:sp>
         <p:nvSpPr>
-          <p:cNvPr id="17" name="Text 15"/>
+          <p:cNvPr id="19" name="Text 17"/>
           <p:cNvSpPr txBox="1"/>
           <p:nvPr/>
         </p:nvSpPr>
@@ -4357,7 +4485,7 @@
       </p:sp>
       <p:sp>
         <p:nvSpPr>
-          <p:cNvPr id="18" name="Text 16"/>
+          <p:cNvPr id="20" name="Text 18"/>
           <p:cNvSpPr txBox="1"/>
           <p:nvPr/>
         </p:nvSpPr>
@@ -4407,7 +4535,7 @@
       </p:sp>
       <p:sp>
         <p:nvSpPr>
-          <p:cNvPr id="19" name="Text 17"/>
+          <p:cNvPr id="21" name="Text 19"/>
           <p:cNvSpPr txBox="1"/>
           <p:nvPr/>
         </p:nvSpPr>
@@ -4443,7 +4571,7 @@
       </p:sp>
       <p:sp>
         <p:nvSpPr>
-          <p:cNvPr id="20" name="Text 18"/>
+          <p:cNvPr id="22" name="Text 20"/>
           <p:cNvSpPr txBox="1"/>
           <p:nvPr/>
         </p:nvSpPr>
@@ -4493,7 +4621,7 @@
       </p:sp>
       <p:sp>
         <p:nvSpPr>
-          <p:cNvPr id="21" name="Text 19"/>
+          <p:cNvPr id="23" name="Text 21"/>
           <p:cNvSpPr txBox="1"/>
           <p:nvPr/>
         </p:nvSpPr>
@@ -4529,7 +4657,7 @@
       </p:sp>
       <p:sp>
         <p:nvSpPr>
-          <p:cNvPr id="22" name="Lengkapi kode customer per dek di SAP"/>
+          <p:cNvPr id="24" name="Siapkan akun dan level approval"/>
           <p:cNvSpPr/>
           <p:nvPr/>
         </p:nvSpPr>
@@ -4556,7 +4684,7 @@
       </p:sp>
       <p:sp>
         <p:nvSpPr>
-          <p:cNvPr id="23" name="Text 21"/>
+          <p:cNvPr id="25" name="Text 23"/>
           <p:cNvSpPr txBox="1"/>
           <p:nvPr/>
         </p:nvSpPr>
@@ -4592,7 +4720,7 @@
       </p:sp>
       <p:sp>
         <p:nvSpPr>
-          <p:cNvPr id="24" name="Text 22"/>
+          <p:cNvPr id="26" name="Text 24"/>
           <p:cNvSpPr txBox="1"/>
           <p:nvPr/>
         </p:nvSpPr>
@@ -4620,7 +4748,7 @@
                   <a:srgbClr val="FFFFFF"/>
                 </a:solidFill>
               </a:rPr>
-              <a:t>Lengkapi kode customer per dek di SAP</a:t>
+              <a:t>Siapkan akun dan level approval</a:t>
             </a:r>
             <a:endParaRPr lang="en-US" sz="1500" dirty="0"/>
           </a:p>
@@ -4634,7 +4762,7 @@
                   <a:srgbClr val="CADCFC"/>
                 </a:solidFill>
               </a:rPr>
-              <a:t>menutup temuan terbuka</a:t>
+              <a:t>untuk setiap peran dan kapal</a:t>
             </a:r>
             <a:endParaRPr lang="en-US" sz="1500" dirty="0"/>
           </a:p>
@@ -4642,7 +4770,7 @@
       </p:sp>
       <p:sp>
         <p:nvSpPr>
-          <p:cNvPr id="25" name="Pilot di satu kapal (KM Awu)"/>
+          <p:cNvPr id="27" name="Pilot di satu kapal (KM Awu)"/>
           <p:cNvSpPr/>
           <p:nvPr/>
         </p:nvSpPr>
@@ -4669,7 +4797,7 @@
       </p:sp>
       <p:sp>
         <p:nvSpPr>
-          <p:cNvPr id="26" name="Text 24"/>
+          <p:cNvPr id="28" name="Text 26"/>
           <p:cNvSpPr txBox="1"/>
           <p:nvPr/>
         </p:nvSpPr>
@@ -4705,7 +4833,7 @@
       </p:sp>
       <p:sp>
         <p:nvSpPr>
-          <p:cNvPr id="27" name="Text 25"/>
+          <p:cNvPr id="29" name="Text 27"/>
           <p:cNvSpPr txBox="1"/>
           <p:nvPr/>
         </p:nvSpPr>
@@ -4755,7 +4883,7 @@
       </p:sp>
       <p:sp>
         <p:nvSpPr>
-          <p:cNvPr id="28" name="Sosialisasi ke seluruh peran"/>
+          <p:cNvPr id="30" name="Sosialisasi ke seluruh peran"/>
           <p:cNvSpPr/>
           <p:nvPr/>
         </p:nvSpPr>
@@ -4782,7 +4910,7 @@
       </p:sp>
       <p:sp>
         <p:nvSpPr>
-          <p:cNvPr id="29" name="Text 27"/>
+          <p:cNvPr id="31" name="Text 29"/>
           <p:cNvSpPr txBox="1"/>
           <p:nvPr/>
         </p:nvSpPr>
@@ -4818,7 +4946,7 @@
       </p:sp>
       <p:sp>
         <p:nvSpPr>
-          <p:cNvPr id="30" name="Text 28"/>
+          <p:cNvPr id="32" name="Text 30"/>
           <p:cNvSpPr txBox="1"/>
           <p:nvPr/>
         </p:nvSpPr>

</xml_diff>

<commit_message>
Paparan direksi: halaman 3 jadi ringkasan dan penutup
Co-Authored-By: Claude Opus 5.5 <noreply@anthropic.com>
Claude-Session: https://claude.ai/code/session_01JEY5regGSA4jYBqyTUCMow
</commit_message>
<xml_diff>
--- a/docs/PID_POS_Paparan_Direksi.pptx
+++ b/docs/PID_POS_Paparan_Direksi.pptx
@@ -680,7 +680,7 @@
           <a:p>
             <a:r>
               <a:rPr lang="en-US" dirty="0"/>
-              <a:t>PID POS dipakai di tiga tempat: di kapal oleh kepala toko dan kasir, di DC oleh admin gudang, dan di kantor pusat oleh para penyetuju dan admin purchase. Materi sosialisasi sudah siap: manual book per peran, sembilan video tutorial, dan empat video pendek. Usulan langkah berikutnya: menyiapkan akun dan level approval untuk setiap peran, menjalankan pilot di satu kapal dengan SAP produksi, lalu sosialisasi ke seluruh peran.</a:t>
+              <a:t>Sebagai penutup, ada tiga hal yang perlu diingat. Pertama, PID POS menyatukan seluruh alur barang toko kapal, dari permintaan sampai penjualan, dalam satu aplikasi. Kedua, setiap dokumen dibuat otomatis di SAP setelah disetujui, tanpa input ulang. Ketiga, setiap permintaan dan persetujuan terlacak. Untuk itu kami memohon dukungan Direksi: persetujuan penerapan PID POS, serta arahan kepada unit terkait untuk menjalankan prosesnya melalui PID POS. Terima kasih.</a:t>
             </a:r>
             <a:endParaRPr lang="en-US" dirty="0"/>
           </a:p>
@@ -928,6 +928,158 @@
 </p:sldLayout>
 </file>
 
+<file path=ppt/slideLayouts/slideLayout3.xml><?xml version="1.0" encoding="utf-8"?>
+<p:sldLayout xmlns:a="http://schemas.openxmlformats.org/drawingml/2006/main" xmlns:r="http://schemas.openxmlformats.org/officeDocument/2006/relationships" xmlns:p="http://schemas.openxmlformats.org/presentationml/2006/main" preserve="1">
+  <p:cSld name="PENUTUP">
+    <p:bg>
+      <p:bgPr>
+        <a:solidFill>
+          <a:srgbClr val="1F3B7A"/>
+        </a:solidFill>
+      </p:bgPr>
+    </p:bg>
+    <p:spTree>
+      <p:nvGrpSpPr>
+        <p:cNvPr id="1" name=""/>
+        <p:cNvGrpSpPr/>
+        <p:nvPr/>
+      </p:nvGrpSpPr>
+      <p:grpSpPr>
+        <a:xfrm>
+          <a:off x="0" y="0"/>
+          <a:ext cx="0" cy="0"/>
+          <a:chOff x="0" y="0"/>
+          <a:chExt cx="0" cy="0"/>
+        </a:xfrm>
+      </p:grpSpPr>
+      <p:sp>
+        <p:nvSpPr>
+          <p:cNvPr id="2" name="Text 0"/>
+          <p:cNvSpPr/>
+          <p:nvPr>
+            <p:ph idx="100" type="title" hasCustomPrompt="1"/>
+          </p:nvPr>
+        </p:nvSpPr>
+        <p:spPr>
+          <a:xfrm>
+            <a:off x="457200" y="365760"/>
+            <a:ext cx="11274552" cy="731520"/>
+          </a:xfrm>
+          <a:prstGeom prst="rect">
+            <a:avLst/>
+          </a:prstGeom>
+          <a:noFill/>
+          <a:ln/>
+        </p:spPr>
+        <p:txBody>
+          <a:bodyPr wrap="square" rtlCol="0"/>
+          <a:lstStyle>
+            <a:lvl1pPr algn="l" indent="0" marL="0">
+              <a:buNone/>
+              <a:defRPr lang="en-US" sz="3400" b="1" dirty="0">
+                <a:solidFill>
+                  <a:schemeClr val="bg1"/>
+                </a:solidFill>
+              </a:defRPr>
+            </a:lvl1pPr>
+          </a:lstStyle>
+          <a:p>
+            <a:pPr algn="l" indent="0" marL="0">
+              <a:buNone/>
+            </a:pPr>
+            <a:endParaRPr lang="en-US" sz="3400" dirty="0"/>
+          </a:p>
+        </p:txBody>
+      </p:sp>
+      <p:sp>
+        <p:nvSpPr>
+          <p:cNvPr id="3" name="Text 0"/>
+          <p:cNvSpPr/>
+          <p:nvPr/>
+        </p:nvSpPr>
+        <p:spPr>
+          <a:xfrm>
+            <a:off x="457200" y="6400800"/>
+            <a:ext cx="7315200" cy="274320"/>
+          </a:xfrm>
+          <a:prstGeom prst="rect">
+            <a:avLst/>
+          </a:prstGeom>
+          <a:noFill/>
+          <a:ln/>
+        </p:spPr>
+        <p:txBody>
+          <a:bodyPr wrap="square" lIns="0" tIns="0" rIns="0" bIns="0" rtlCol="0" anchor="ctr"/>
+          <a:lstStyle/>
+          <a:p>
+            <a:pPr indent="0" marL="0">
+              <a:buNone/>
+            </a:pPr>
+            <a:r>
+              <a:rPr lang="en-US" sz="1000" dirty="0">
+                <a:solidFill>
+                  <a:schemeClr val="bg2"/>
+                </a:solidFill>
+              </a:rPr>
+              <a:t>PID POS · Paparan direksi</a:t>
+            </a:r>
+            <a:endParaRPr lang="en-US" sz="1000" dirty="0"/>
+          </a:p>
+        </p:txBody>
+      </p:sp>
+      <p:sp>
+        <p:nvSpPr>
+          <p:cNvPr id="25" name="Slide Number Placeholder 0"/>
+          <p:cNvSpPr>
+            <a:spLocks noGrp="1"/>
+          </p:cNvSpPr>
+          <p:nvPr>
+            <p:ph type="sldNum" sz="quarter" idx="4294967295"/>
+          </p:nvPr>
+        </p:nvSpPr>
+        <p:spPr>
+          <a:xfrm>
+            <a:off x="11338560" y="6400800"/>
+            <a:ext cx="457200" cy="274320"/>
+          </a:xfrm>
+          <a:prstGeom prst="rect">
+            <a:avLst/>
+          </a:prstGeom>
+          <a:extLst>
+            <a:ext uri="{C572A759-6A51-4108-AA02-DFA0A04FC94B}">
+              <ma14:wrappingTextBoxFlag xmlns:ma14="http://schemas.microsoft.com/office/mac/drawingml/2011/main" val="0"/>
+            </a:ext>
+          </a:extLst>
+        </p:spPr>
+        <p:txBody>
+          <a:bodyPr/>
+          <a:lstStyle>
+            <a:lvl1pPr>
+              <a:defRPr sz="1000">
+                <a:solidFill>
+                  <a:srgbClr val="CADCFC"/>
+                </a:solidFill>
+              </a:defRPr>
+            </a:lvl1pPr>
+          </a:lstStyle>
+          <a:p>
+            <a:pPr algn="r"/>
+            <a:fld id="{F7021451-1387-4CA6-816F-3879F97B5CBC}" type="slidenum">
+              <a:rPr b="0" lang="en-US"/>
+              <a:t>1003</a:t>
+            </a:fld>
+            <a:endParaRPr lang="en-US"/>
+          </a:p>
+        </p:txBody>
+      </p:sp>
+    </p:spTree>
+  </p:cSld>
+  <p:clrMapOvr>
+    <a:masterClrMapping/>
+  </p:clrMapOvr>
+</p:sldLayout>
+</file>
+
 <file path=ppt/slideMasters/slideMaster1.xml><?xml version="1.0" encoding="utf-8"?>
 <p:sldMaster xmlns:a="http://schemas.openxmlformats.org/drawingml/2006/main" xmlns:r="http://schemas.openxmlformats.org/officeDocument/2006/relationships" xmlns:p="http://schemas.openxmlformats.org/presentationml/2006/main">
   <p:cSld>
@@ -996,6 +1148,7 @@
   <p:sldLayoutIdLst>
     <p:sldLayoutId id="2147483649" r:id="rId1"/>
     <p:sldLayoutId id="2147483650" r:id="rId2"/>
+    <p:sldLayoutId id="2147483651" r:id="rId3"/>
   </p:sldLayoutIdLst>
   <p:hf sldNum="0" hdr="0" ftr="0" dt="0"/>
   <p:txStyles>
@@ -3767,8 +3920,8 @@
         </p:nvSpPr>
         <p:spPr>
           <a:xfrm>
-            <a:off x="457200" y="320040"/>
-            <a:ext cx="9509760" cy="685800"/>
+            <a:off x="457200" y="365760"/>
+            <a:ext cx="11274552" cy="731520"/>
           </a:xfrm>
           <a:prstGeom prst="rect">
             <a:avLst/>
@@ -3786,10 +3939,10 @@
             <a:r>
               <a:rPr lang="en-US" sz="3400" b="1" dirty="0">
                 <a:solidFill>
-                  <a:schemeClr val="tx2"/>
-                </a:solidFill>
-              </a:rPr>
-              <a:t>Siap diterapkan di kapal, DC, dan kantor pusat</a:t>
+                  <a:schemeClr val="bg1"/>
+                </a:solidFill>
+              </a:rPr>
+              <a:t>Ringkasan: tiga hal yang perlu diingat</a:t>
             </a:r>
             <a:endParaRPr lang="en-US" sz="3400" dirty="0"/>
           </a:p>
@@ -3797,26 +3950,26 @@
       </p:sp>
       <p:sp>
         <p:nvSpPr>
-          <p:cNvPr id="3" name="Pengguna"/>
+          <p:cNvPr id="3" name="Satu alur terintegrasi"/>
           <p:cNvSpPr/>
           <p:nvPr/>
         </p:nvSpPr>
         <p:spPr>
           <a:xfrm>
-            <a:off x="457200" y="1188720"/>
-            <a:ext cx="5486400" cy="3246120"/>
+            <a:off x="457200" y="1325880"/>
+            <a:ext cx="3611880" cy="2514600"/>
           </a:xfrm>
           <a:prstGeom prst="roundRect">
             <a:avLst>
-              <a:gd name="adj" fmla="val 3380"/>
+              <a:gd name="adj" fmla="val 4364"/>
             </a:avLst>
           </a:prstGeom>
           <a:solidFill>
-            <a:srgbClr val="EEF3FB"/>
+            <a:srgbClr val="2A4A8F"/>
           </a:solidFill>
           <a:ln w="12700">
             <a:solidFill>
-              <a:srgbClr val="EEF3FB"/>
+              <a:srgbClr val="2A4A8F"/>
             </a:solidFill>
             <a:prstDash val="solid"/>
           </a:ln>
@@ -3830,8 +3983,8 @@
         </p:nvSpPr>
         <p:spPr>
           <a:xfrm>
-            <a:off x="685800" y="1325880"/>
-            <a:ext cx="5029200" cy="365760"/>
+            <a:off x="731520" y="1463040"/>
+            <a:ext cx="822960" cy="822960"/>
           </a:xfrm>
           <a:prstGeom prst="rect">
             <a:avLst/>
@@ -3847,14 +4000,14 @@
               <a:buNone/>
             </a:pPr>
             <a:r>
-              <a:rPr lang="en-US" sz="1800" b="1" dirty="0">
-                <a:solidFill>
-                  <a:srgbClr val="1F3B7A"/>
-                </a:solidFill>
-              </a:rPr>
-              <a:t>Pengguna PID POS</a:t>
-            </a:r>
-            <a:endParaRPr lang="en-US" sz="1800" dirty="0"/>
+              <a:rPr lang="en-US" sz="4800" b="1" dirty="0">
+                <a:solidFill>
+                  <a:srgbClr val="FF6B1A"/>
+                </a:solidFill>
+              </a:rPr>
+              <a:t>1</a:t>
+            </a:r>
+            <a:endParaRPr lang="en-US" sz="4800" dirty="0"/>
           </a:p>
         </p:txBody>
       </p:sp>
@@ -3866,460 +4019,76 @@
         </p:nvSpPr>
         <p:spPr>
           <a:xfrm>
-            <a:off x="685800" y="1828800"/>
-            <a:ext cx="1463040" cy="384048"/>
+            <a:off x="731520" y="2331720"/>
+            <a:ext cx="3108960" cy="1417320"/>
+          </a:xfrm>
+          <a:prstGeom prst="rect">
+            <a:avLst/>
+          </a:prstGeom>
+          <a:noFill/>
+          <a:ln/>
+        </p:spPr>
+        <p:txBody>
+          <a:bodyPr wrap="square" lIns="0" tIns="0" rIns="0" bIns="0" rtlCol="0" anchor="t"/>
+          <a:lstStyle/>
+          <a:p>
+            <a:pPr indent="0" marL="0">
+              <a:spcAft>
+                <a:spcPts val="600"/>
+              </a:spcAft>
+              <a:buNone/>
+            </a:pPr>
+            <a:r>
+              <a:rPr lang="en-US" sz="2000" b="1" dirty="0">
+                <a:solidFill>
+                  <a:srgbClr val="FFFFFF"/>
+                </a:solidFill>
+              </a:rPr>
+              <a:t>Satu alur terintegrasi</a:t>
+            </a:r>
+            <a:endParaRPr lang="en-US" sz="2000" dirty="0"/>
+          </a:p>
+          <a:p>
+            <a:pPr indent="0" marL="0">
+              <a:spcAft>
+                <a:spcPts val="600"/>
+              </a:spcAft>
+              <a:buNone/>
+            </a:pPr>
+            <a:r>
+              <a:rPr lang="en-US" sz="1400" dirty="0">
+                <a:solidFill>
+                  <a:srgbClr val="CADCFC"/>
+                </a:solidFill>
+              </a:rPr>
+              <a:t>Dari permintaan kapal sampai penjualan di kasir: 9 tahap, 7 peran, dalam satu aplikasi.</a:t>
+            </a:r>
+            <a:endParaRPr lang="en-US" sz="2000" dirty="0"/>
+          </a:p>
+        </p:txBody>
+      </p:sp>
+      <p:sp>
+        <p:nvSpPr>
+          <p:cNvPr id="6" name="Otomatis ke SAP"/>
+          <p:cNvSpPr/>
+          <p:nvPr/>
+        </p:nvSpPr>
+        <p:spPr>
+          <a:xfrm>
+            <a:off x="4251960" y="1325880"/>
+            <a:ext cx="3611880" cy="2514600"/>
           </a:xfrm>
           <a:prstGeom prst="roundRect">
             <a:avLst>
-              <a:gd name="adj" fmla="val 19048"/>
+              <a:gd name="adj" fmla="val 4364"/>
             </a:avLst>
           </a:prstGeom>
           <a:solidFill>
-            <a:srgbClr val="0F766E"/>
-          </a:solidFill>
-          <a:ln>
-            <a:solidFill>
-              <a:srgbClr val="0F766E"/>
-            </a:solidFill>
-          </a:ln>
-        </p:spPr>
-        <p:txBody>
-          <a:bodyPr wrap="square" lIns="0" tIns="0" rIns="0" bIns="0" rtlCol="0" anchor="ctr"/>
-          <a:lstStyle/>
-          <a:p>
-            <a:pPr algn="ctr" indent="0" marL="0">
-              <a:buNone/>
-            </a:pPr>
-            <a:r>
-              <a:rPr lang="en-US" sz="1300" b="1" dirty="0">
-                <a:solidFill>
-                  <a:srgbClr val="FFFFFF"/>
-                </a:solidFill>
-              </a:rPr>
-              <a:t>Kapal</a:t>
-            </a:r>
-            <a:endParaRPr lang="en-US" sz="1300" dirty="0"/>
-          </a:p>
-        </p:txBody>
-      </p:sp>
-      <p:sp>
-        <p:nvSpPr>
-          <p:cNvPr id="6" name="Text 4"/>
-          <p:cNvSpPr txBox="1"/>
-          <p:nvPr/>
-        </p:nvSpPr>
-        <p:spPr>
-          <a:xfrm>
-            <a:off x="2286000" y="1828800"/>
-            <a:ext cx="1691640" cy="384048"/>
-          </a:xfrm>
-          <a:prstGeom prst="roundRect">
-            <a:avLst>
-              <a:gd name="adj" fmla="val 19048"/>
-            </a:avLst>
-          </a:prstGeom>
-          <a:solidFill>
-            <a:srgbClr val="FFFFFF"/>
+            <a:srgbClr val="2A4A8F"/>
           </a:solidFill>
           <a:ln w="12700">
             <a:solidFill>
-              <a:srgbClr val="D5DEEC"/>
-            </a:solidFill>
-          </a:ln>
-        </p:spPr>
-        <p:txBody>
-          <a:bodyPr wrap="square" lIns="0" tIns="0" rIns="0" bIns="0" rtlCol="0" anchor="ctr"/>
-          <a:lstStyle/>
-          <a:p>
-            <a:pPr algn="ctr" indent="0" marL="0">
-              <a:buNone/>
-            </a:pPr>
-            <a:r>
-              <a:rPr lang="en-US" sz="1200" dirty="0">
-                <a:solidFill>
-                  <a:srgbClr val="1B2437"/>
-                </a:solidFill>
-              </a:rPr>
-              <a:t>Kepala Toko / Admin Kapal</a:t>
-            </a:r>
-            <a:endParaRPr lang="en-US" sz="1200" dirty="0"/>
-          </a:p>
-        </p:txBody>
-      </p:sp>
-      <p:sp>
-        <p:nvSpPr>
-          <p:cNvPr id="7" name="Text 5"/>
-          <p:cNvSpPr txBox="1"/>
-          <p:nvPr/>
-        </p:nvSpPr>
-        <p:spPr>
-          <a:xfrm>
-            <a:off x="4069080" y="1828800"/>
-            <a:ext cx="1691640" cy="384048"/>
-          </a:xfrm>
-          <a:prstGeom prst="roundRect">
-            <a:avLst>
-              <a:gd name="adj" fmla="val 19048"/>
-            </a:avLst>
-          </a:prstGeom>
-          <a:solidFill>
-            <a:srgbClr val="FFFFFF"/>
-          </a:solidFill>
-          <a:ln w="12700">
-            <a:solidFill>
-              <a:srgbClr val="D5DEEC"/>
-            </a:solidFill>
-          </a:ln>
-        </p:spPr>
-        <p:txBody>
-          <a:bodyPr wrap="square" lIns="0" tIns="0" rIns="0" bIns="0" rtlCol="0" anchor="ctr"/>
-          <a:lstStyle/>
-          <a:p>
-            <a:pPr algn="ctr" indent="0" marL="0">
-              <a:buNone/>
-            </a:pPr>
-            <a:r>
-              <a:rPr lang="en-US" sz="1200" dirty="0">
-                <a:solidFill>
-                  <a:srgbClr val="1B2437"/>
-                </a:solidFill>
-              </a:rPr>
-              <a:t>Kasir (per dek)</a:t>
-            </a:r>
-            <a:endParaRPr lang="en-US" sz="1200" dirty="0"/>
-          </a:p>
-        </p:txBody>
-      </p:sp>
-      <p:sp>
-        <p:nvSpPr>
-          <p:cNvPr id="8" name="Text 6"/>
-          <p:cNvSpPr txBox="1"/>
-          <p:nvPr/>
-        </p:nvSpPr>
-        <p:spPr>
-          <a:xfrm>
-            <a:off x="685800" y="2487168"/>
-            <a:ext cx="1463040" cy="384048"/>
-          </a:xfrm>
-          <a:prstGeom prst="roundRect">
-            <a:avLst>
-              <a:gd name="adj" fmla="val 19048"/>
-            </a:avLst>
-          </a:prstGeom>
-          <a:solidFill>
-            <a:srgbClr val="EA580C"/>
-          </a:solidFill>
-          <a:ln>
-            <a:solidFill>
-              <a:srgbClr val="EA580C"/>
-            </a:solidFill>
-          </a:ln>
-        </p:spPr>
-        <p:txBody>
-          <a:bodyPr wrap="square" lIns="0" tIns="0" rIns="0" bIns="0" rtlCol="0" anchor="ctr"/>
-          <a:lstStyle/>
-          <a:p>
-            <a:pPr algn="ctr" indent="0" marL="0">
-              <a:buNone/>
-            </a:pPr>
-            <a:r>
-              <a:rPr lang="en-US" sz="1300" b="1" dirty="0">
-                <a:solidFill>
-                  <a:srgbClr val="FFFFFF"/>
-                </a:solidFill>
-              </a:rPr>
-              <a:t>DC / Gudang</a:t>
-            </a:r>
-            <a:endParaRPr lang="en-US" sz="1300" dirty="0"/>
-          </a:p>
-        </p:txBody>
-      </p:sp>
-      <p:sp>
-        <p:nvSpPr>
-          <p:cNvPr id="9" name="Text 7"/>
-          <p:cNvSpPr txBox="1"/>
-          <p:nvPr/>
-        </p:nvSpPr>
-        <p:spPr>
-          <a:xfrm>
-            <a:off x="2286000" y="2487168"/>
-            <a:ext cx="1691640" cy="384048"/>
-          </a:xfrm>
-          <a:prstGeom prst="roundRect">
-            <a:avLst>
-              <a:gd name="adj" fmla="val 19048"/>
-            </a:avLst>
-          </a:prstGeom>
-          <a:solidFill>
-            <a:srgbClr val="FFFFFF"/>
-          </a:solidFill>
-          <a:ln w="12700">
-            <a:solidFill>
-              <a:srgbClr val="D5DEEC"/>
-            </a:solidFill>
-          </a:ln>
-        </p:spPr>
-        <p:txBody>
-          <a:bodyPr wrap="square" lIns="0" tIns="0" rIns="0" bIns="0" rtlCol="0" anchor="ctr"/>
-          <a:lstStyle/>
-          <a:p>
-            <a:pPr algn="ctr" indent="0" marL="0">
-              <a:buNone/>
-            </a:pPr>
-            <a:r>
-              <a:rPr lang="en-US" sz="1200" dirty="0">
-                <a:solidFill>
-                  <a:srgbClr val="1B2437"/>
-                </a:solidFill>
-              </a:rPr>
-              <a:t>Admin DC</a:t>
-            </a:r>
-            <a:endParaRPr lang="en-US" sz="1200" dirty="0"/>
-          </a:p>
-        </p:txBody>
-      </p:sp>
-      <p:sp>
-        <p:nvSpPr>
-          <p:cNvPr id="10" name="Text 8"/>
-          <p:cNvSpPr txBox="1"/>
-          <p:nvPr/>
-        </p:nvSpPr>
-        <p:spPr>
-          <a:xfrm>
-            <a:off x="685800" y="3145536"/>
-            <a:ext cx="1463040" cy="384048"/>
-          </a:xfrm>
-          <a:prstGeom prst="roundRect">
-            <a:avLst>
-              <a:gd name="adj" fmla="val 19048"/>
-            </a:avLst>
-          </a:prstGeom>
-          <a:solidFill>
-            <a:srgbClr val="2563EB"/>
-          </a:solidFill>
-          <a:ln>
-            <a:solidFill>
-              <a:srgbClr val="2563EB"/>
-            </a:solidFill>
-          </a:ln>
-        </p:spPr>
-        <p:txBody>
-          <a:bodyPr wrap="square" lIns="0" tIns="0" rIns="0" bIns="0" rtlCol="0" anchor="ctr"/>
-          <a:lstStyle/>
-          <a:p>
-            <a:pPr algn="ctr" indent="0" marL="0">
-              <a:buNone/>
-            </a:pPr>
-            <a:r>
-              <a:rPr lang="en-US" sz="1300" b="1" dirty="0">
-                <a:solidFill>
-                  <a:srgbClr val="FFFFFF"/>
-                </a:solidFill>
-              </a:rPr>
-              <a:t>Kantor pusat</a:t>
-            </a:r>
-            <a:endParaRPr lang="en-US" sz="1300" dirty="0"/>
-          </a:p>
-        </p:txBody>
-      </p:sp>
-      <p:sp>
-        <p:nvSpPr>
-          <p:cNvPr id="11" name="Text 9"/>
-          <p:cNvSpPr txBox="1"/>
-          <p:nvPr/>
-        </p:nvSpPr>
-        <p:spPr>
-          <a:xfrm>
-            <a:off x="2286000" y="3145536"/>
-            <a:ext cx="1691640" cy="384048"/>
-          </a:xfrm>
-          <a:prstGeom prst="roundRect">
-            <a:avLst>
-              <a:gd name="adj" fmla="val 19048"/>
-            </a:avLst>
-          </a:prstGeom>
-          <a:solidFill>
-            <a:srgbClr val="FFFFFF"/>
-          </a:solidFill>
-          <a:ln w="12700">
-            <a:solidFill>
-              <a:srgbClr val="D5DEEC"/>
-            </a:solidFill>
-          </a:ln>
-        </p:spPr>
-        <p:txBody>
-          <a:bodyPr wrap="square" lIns="0" tIns="0" rIns="0" bIns="0" rtlCol="0" anchor="ctr"/>
-          <a:lstStyle/>
-          <a:p>
-            <a:pPr algn="ctr" indent="0" marL="0">
-              <a:buNone/>
-            </a:pPr>
-            <a:r>
-              <a:rPr lang="en-US" sz="1200" dirty="0">
-                <a:solidFill>
-                  <a:srgbClr val="1B2437"/>
-                </a:solidFill>
-              </a:rPr>
-              <a:t>Approve SO (P2)</a:t>
-            </a:r>
-            <a:endParaRPr lang="en-US" sz="1200" dirty="0"/>
-          </a:p>
-        </p:txBody>
-      </p:sp>
-      <p:sp>
-        <p:nvSpPr>
-          <p:cNvPr id="12" name="Text 10"/>
-          <p:cNvSpPr txBox="1"/>
-          <p:nvPr/>
-        </p:nvSpPr>
-        <p:spPr>
-          <a:xfrm>
-            <a:off x="4069080" y="3145536"/>
-            <a:ext cx="1691640" cy="384048"/>
-          </a:xfrm>
-          <a:prstGeom prst="roundRect">
-            <a:avLst>
-              <a:gd name="adj" fmla="val 19048"/>
-            </a:avLst>
-          </a:prstGeom>
-          <a:solidFill>
-            <a:srgbClr val="FFFFFF"/>
-          </a:solidFill>
-          <a:ln w="12700">
-            <a:solidFill>
-              <a:srgbClr val="D5DEEC"/>
-            </a:solidFill>
-          </a:ln>
-        </p:spPr>
-        <p:txBody>
-          <a:bodyPr wrap="square" lIns="0" tIns="0" rIns="0" bIns="0" rtlCol="0" anchor="ctr"/>
-          <a:lstStyle/>
-          <a:p>
-            <a:pPr algn="ctr" indent="0" marL="0">
-              <a:buNone/>
-            </a:pPr>
-            <a:r>
-              <a:rPr lang="en-US" sz="1200" dirty="0">
-                <a:solidFill>
-                  <a:srgbClr val="1B2437"/>
-                </a:solidFill>
-              </a:rPr>
-              <a:t>Approve PUR</a:t>
-            </a:r>
-            <a:endParaRPr lang="en-US" sz="1200" dirty="0"/>
-          </a:p>
-        </p:txBody>
-      </p:sp>
-      <p:sp>
-        <p:nvSpPr>
-          <p:cNvPr id="13" name="Text 11"/>
-          <p:cNvSpPr txBox="1"/>
-          <p:nvPr/>
-        </p:nvSpPr>
-        <p:spPr>
-          <a:xfrm>
-            <a:off x="2286000" y="3602736"/>
-            <a:ext cx="1691640" cy="384048"/>
-          </a:xfrm>
-          <a:prstGeom prst="roundRect">
-            <a:avLst>
-              <a:gd name="adj" fmla="val 19048"/>
-            </a:avLst>
-          </a:prstGeom>
-          <a:solidFill>
-            <a:srgbClr val="FFFFFF"/>
-          </a:solidFill>
-          <a:ln w="12700">
-            <a:solidFill>
-              <a:srgbClr val="D5DEEC"/>
-            </a:solidFill>
-          </a:ln>
-        </p:spPr>
-        <p:txBody>
-          <a:bodyPr wrap="square" lIns="0" tIns="0" rIns="0" bIns="0" rtlCol="0" anchor="ctr"/>
-          <a:lstStyle/>
-          <a:p>
-            <a:pPr algn="ctr" indent="0" marL="0">
-              <a:buNone/>
-            </a:pPr>
-            <a:r>
-              <a:rPr lang="en-US" sz="1200" dirty="0">
-                <a:solidFill>
-                  <a:srgbClr val="1B2437"/>
-                </a:solidFill>
-              </a:rPr>
-              <a:t>Admin Purchase</a:t>
-            </a:r>
-            <a:endParaRPr lang="en-US" sz="1200" dirty="0"/>
-          </a:p>
-        </p:txBody>
-      </p:sp>
-      <p:sp>
-        <p:nvSpPr>
-          <p:cNvPr id="14" name="Text 12"/>
-          <p:cNvSpPr txBox="1"/>
-          <p:nvPr/>
-        </p:nvSpPr>
-        <p:spPr>
-          <a:xfrm>
-            <a:off x="4069080" y="3602736"/>
-            <a:ext cx="1691640" cy="384048"/>
-          </a:xfrm>
-          <a:prstGeom prst="roundRect">
-            <a:avLst>
-              <a:gd name="adj" fmla="val 19048"/>
-            </a:avLst>
-          </a:prstGeom>
-          <a:solidFill>
-            <a:srgbClr val="FFFFFF"/>
-          </a:solidFill>
-          <a:ln w="12700">
-            <a:solidFill>
-              <a:srgbClr val="D5DEEC"/>
-            </a:solidFill>
-          </a:ln>
-        </p:spPr>
-        <p:txBody>
-          <a:bodyPr wrap="square" lIns="0" tIns="0" rIns="0" bIns="0" rtlCol="0" anchor="ctr"/>
-          <a:lstStyle/>
-          <a:p>
-            <a:pPr algn="ctr" indent="0" marL="0">
-              <a:buNone/>
-            </a:pPr>
-            <a:r>
-              <a:rPr lang="en-US" sz="1200" dirty="0">
-                <a:solidFill>
-                  <a:srgbClr val="1B2437"/>
-                </a:solidFill>
-              </a:rPr>
-              <a:t>Approve PO</a:t>
-            </a:r>
-            <a:endParaRPr lang="en-US" sz="1200" dirty="0"/>
-          </a:p>
-        </p:txBody>
-      </p:sp>
-      <p:sp>
-        <p:nvSpPr>
-          <p:cNvPr id="15" name="Materi sosialisasi"/>
-          <p:cNvSpPr/>
-          <p:nvPr/>
-        </p:nvSpPr>
-        <p:spPr>
-          <a:xfrm>
-            <a:off x="6245352" y="1188720"/>
-            <a:ext cx="5486400" cy="3246120"/>
-          </a:xfrm>
-          <a:prstGeom prst="roundRect">
-            <a:avLst>
-              <a:gd name="adj" fmla="val 3380"/>
-            </a:avLst>
-          </a:prstGeom>
-          <a:solidFill>
-            <a:srgbClr val="EEF3FB"/>
-          </a:solidFill>
-          <a:ln w="12700">
-            <a:solidFill>
-              <a:srgbClr val="EEF3FB"/>
+              <a:srgbClr val="2A4A8F"/>
             </a:solidFill>
             <a:prstDash val="solid"/>
           </a:ln>
@@ -4327,14 +4096,14 @@
       </p:sp>
       <p:sp>
         <p:nvSpPr>
-          <p:cNvPr id="16" name="Text 14"/>
+          <p:cNvPr id="7" name="Text 5"/>
           <p:cNvSpPr txBox="1"/>
           <p:nvPr/>
         </p:nvSpPr>
         <p:spPr>
           <a:xfrm>
-            <a:off x="6473952" y="1325880"/>
-            <a:ext cx="5029200" cy="365760"/>
+            <a:off x="4526280" y="1463040"/>
+            <a:ext cx="822960" cy="822960"/>
           </a:xfrm>
           <a:prstGeom prst="rect">
             <a:avLst/>
@@ -4350,27 +4119,27 @@
               <a:buNone/>
             </a:pPr>
             <a:r>
-              <a:rPr lang="en-US" sz="1800" b="1" dirty="0">
-                <a:solidFill>
-                  <a:srgbClr val="1F3B7A"/>
-                </a:solidFill>
-              </a:rPr>
-              <a:t>Materi sosialisasi siap</a:t>
-            </a:r>
-            <a:endParaRPr lang="en-US" sz="1800" dirty="0"/>
-          </a:p>
-        </p:txBody>
-      </p:sp>
-      <p:sp>
-        <p:nvSpPr>
-          <p:cNvPr id="17" name="Text 15"/>
+              <a:rPr lang="en-US" sz="4800" b="1" dirty="0">
+                <a:solidFill>
+                  <a:srgbClr val="FF6B1A"/>
+                </a:solidFill>
+              </a:rPr>
+              <a:t>2</a:t>
+            </a:r>
+            <a:endParaRPr lang="en-US" sz="4800" dirty="0"/>
+          </a:p>
+        </p:txBody>
+      </p:sp>
+      <p:sp>
+        <p:nvSpPr>
+          <p:cNvPr id="8" name="Text 6"/>
           <p:cNvSpPr txBox="1"/>
           <p:nvPr/>
         </p:nvSpPr>
         <p:spPr>
           <a:xfrm>
-            <a:off x="6473952" y="1874520"/>
-            <a:ext cx="1554480" cy="914400"/>
+            <a:off x="4526280" y="2331720"/>
+            <a:ext cx="3108960" cy="1417320"/>
           </a:xfrm>
           <a:prstGeom prst="rect">
             <a:avLst/>
@@ -4379,304 +4148,66 @@
           <a:ln/>
         </p:spPr>
         <p:txBody>
-          <a:bodyPr wrap="square" lIns="0" tIns="0" rIns="0" bIns="0" rtlCol="0" anchor="ctr"/>
-          <a:lstStyle/>
-          <a:p>
-            <a:pPr indent="0" marL="0">
-              <a:buNone/>
-            </a:pPr>
-            <a:r>
-              <a:rPr lang="en-US" sz="5400" b="1" dirty="0">
-                <a:solidFill>
-                  <a:srgbClr val="1F3B7A"/>
-                </a:solidFill>
-              </a:rPr>
-              <a:t>1</a:t>
-            </a:r>
-            <a:endParaRPr lang="en-US" sz="5400" dirty="0"/>
-          </a:p>
-        </p:txBody>
-      </p:sp>
-      <p:sp>
-        <p:nvSpPr>
-          <p:cNvPr id="18" name="Text 16"/>
-          <p:cNvSpPr txBox="1"/>
-          <p:nvPr/>
-        </p:nvSpPr>
-        <p:spPr>
-          <a:xfrm>
-            <a:off x="6473952" y="2834640"/>
-            <a:ext cx="1600200" cy="914400"/>
-          </a:xfrm>
-          <a:prstGeom prst="rect">
-            <a:avLst/>
-          </a:prstGeom>
-          <a:noFill/>
-          <a:ln/>
-        </p:spPr>
-        <p:txBody>
           <a:bodyPr wrap="square" lIns="0" tIns="0" rIns="0" bIns="0" rtlCol="0" anchor="t"/>
           <a:lstStyle/>
           <a:p>
             <a:pPr indent="0" marL="0">
-              <a:buNone/>
-            </a:pPr>
-            <a:r>
-              <a:rPr lang="en-US" sz="1500" b="1" dirty="0">
-                <a:solidFill>
-                  <a:srgbClr val="1B2437"/>
-                </a:solidFill>
-              </a:rPr>
-              <a:t>Manual book</a:t>
-            </a:r>
-            <a:endParaRPr lang="en-US" sz="1500" dirty="0"/>
-          </a:p>
-          <a:p>
-            <a:pPr indent="0" marL="0">
-              <a:buNone/>
-            </a:pPr>
-            <a:r>
-              <a:rPr lang="en-US" sz="1200" dirty="0">
-                <a:solidFill>
-                  <a:srgbClr val="5B6B86"/>
-                </a:solidFill>
-              </a:rPr>
-              <a:t>per peran, 44 halaman</a:t>
-            </a:r>
-            <a:endParaRPr lang="en-US" sz="1500" dirty="0"/>
-          </a:p>
-        </p:txBody>
-      </p:sp>
-      <p:sp>
-        <p:nvSpPr>
-          <p:cNvPr id="19" name="Text 17"/>
-          <p:cNvSpPr txBox="1"/>
-          <p:nvPr/>
-        </p:nvSpPr>
-        <p:spPr>
-          <a:xfrm>
-            <a:off x="8193024" y="1874520"/>
-            <a:ext cx="1554480" cy="914400"/>
-          </a:xfrm>
-          <a:prstGeom prst="rect">
-            <a:avLst/>
-          </a:prstGeom>
-          <a:noFill/>
-          <a:ln/>
-        </p:spPr>
-        <p:txBody>
-          <a:bodyPr wrap="square" lIns="0" tIns="0" rIns="0" bIns="0" rtlCol="0" anchor="ctr"/>
-          <a:lstStyle/>
-          <a:p>
-            <a:pPr indent="0" marL="0">
-              <a:buNone/>
-            </a:pPr>
-            <a:r>
-              <a:rPr lang="en-US" sz="5400" b="1" dirty="0">
-                <a:solidFill>
-                  <a:srgbClr val="1F3B7A"/>
-                </a:solidFill>
-              </a:rPr>
-              <a:t>9</a:t>
-            </a:r>
-            <a:endParaRPr lang="en-US" sz="5400" dirty="0"/>
-          </a:p>
-        </p:txBody>
-      </p:sp>
-      <p:sp>
-        <p:nvSpPr>
-          <p:cNvPr id="20" name="Text 18"/>
-          <p:cNvSpPr txBox="1"/>
-          <p:nvPr/>
-        </p:nvSpPr>
-        <p:spPr>
-          <a:xfrm>
-            <a:off x="8193024" y="2834640"/>
-            <a:ext cx="1600200" cy="914400"/>
-          </a:xfrm>
-          <a:prstGeom prst="rect">
-            <a:avLst/>
-          </a:prstGeom>
-          <a:noFill/>
-          <a:ln/>
-        </p:spPr>
-        <p:txBody>
-          <a:bodyPr wrap="square" lIns="0" tIns="0" rIns="0" bIns="0" rtlCol="0" anchor="t"/>
-          <a:lstStyle/>
-          <a:p>
-            <a:pPr indent="0" marL="0">
-              <a:buNone/>
-            </a:pPr>
-            <a:r>
-              <a:rPr lang="en-US" sz="1500" b="1" dirty="0">
-                <a:solidFill>
-                  <a:srgbClr val="1B2437"/>
-                </a:solidFill>
-              </a:rPr>
-              <a:t>video tutorial</a:t>
-            </a:r>
-            <a:endParaRPr lang="en-US" sz="1500" dirty="0"/>
-          </a:p>
-          <a:p>
-            <a:pPr indent="0" marL="0">
-              <a:buNone/>
-            </a:pPr>
-            <a:r>
-              <a:rPr lang="en-US" sz="1200" dirty="0">
-                <a:solidFill>
-                  <a:srgbClr val="5B6B86"/>
-                </a:solidFill>
-              </a:rPr>
-              <a:t>alur lengkap + per peran</a:t>
-            </a:r>
-            <a:endParaRPr lang="en-US" sz="1500" dirty="0"/>
-          </a:p>
-        </p:txBody>
-      </p:sp>
-      <p:sp>
-        <p:nvSpPr>
-          <p:cNvPr id="21" name="Text 19"/>
-          <p:cNvSpPr txBox="1"/>
-          <p:nvPr/>
-        </p:nvSpPr>
-        <p:spPr>
-          <a:xfrm>
-            <a:off x="9912096" y="1874520"/>
-            <a:ext cx="1554480" cy="914400"/>
-          </a:xfrm>
-          <a:prstGeom prst="rect">
-            <a:avLst/>
-          </a:prstGeom>
-          <a:noFill/>
-          <a:ln/>
-        </p:spPr>
-        <p:txBody>
-          <a:bodyPr wrap="square" lIns="0" tIns="0" rIns="0" bIns="0" rtlCol="0" anchor="ctr"/>
-          <a:lstStyle/>
-          <a:p>
-            <a:pPr indent="0" marL="0">
-              <a:buNone/>
-            </a:pPr>
-            <a:r>
-              <a:rPr lang="en-US" sz="5400" b="1" dirty="0">
-                <a:solidFill>
-                  <a:srgbClr val="1F3B7A"/>
-                </a:solidFill>
-              </a:rPr>
-              <a:t>4</a:t>
-            </a:r>
-            <a:endParaRPr lang="en-US" sz="5400" dirty="0"/>
-          </a:p>
-        </p:txBody>
-      </p:sp>
-      <p:sp>
-        <p:nvSpPr>
-          <p:cNvPr id="22" name="Text 20"/>
-          <p:cNvSpPr txBox="1"/>
-          <p:nvPr/>
-        </p:nvSpPr>
-        <p:spPr>
-          <a:xfrm>
-            <a:off x="9912096" y="2834640"/>
-            <a:ext cx="1600200" cy="914400"/>
-          </a:xfrm>
-          <a:prstGeom prst="rect">
-            <a:avLst/>
-          </a:prstGeom>
-          <a:noFill/>
-          <a:ln/>
-        </p:spPr>
-        <p:txBody>
-          <a:bodyPr wrap="square" lIns="0" tIns="0" rIns="0" bIns="0" rtlCol="0" anchor="t"/>
-          <a:lstStyle/>
-          <a:p>
-            <a:pPr indent="0" marL="0">
-              <a:buNone/>
-            </a:pPr>
-            <a:r>
-              <a:rPr lang="en-US" sz="1500" b="1" dirty="0">
-                <a:solidFill>
-                  <a:srgbClr val="1B2437"/>
-                </a:solidFill>
-              </a:rPr>
-              <a:t>video pendek</a:t>
-            </a:r>
-            <a:endParaRPr lang="en-US" sz="1500" dirty="0"/>
-          </a:p>
-          <a:p>
-            <a:pPr indent="0" marL="0">
-              <a:buNone/>
-            </a:pPr>
-            <a:r>
-              <a:rPr lang="en-US" sz="1200" dirty="0">
-                <a:solidFill>
-                  <a:srgbClr val="5B6B86"/>
-                </a:solidFill>
-              </a:rPr>
-              <a:t>format media sosial</a:t>
-            </a:r>
-            <a:endParaRPr lang="en-US" sz="1500" dirty="0"/>
-          </a:p>
-        </p:txBody>
-      </p:sp>
-      <p:sp>
-        <p:nvSpPr>
-          <p:cNvPr id="23" name="Text 21"/>
-          <p:cNvSpPr txBox="1"/>
-          <p:nvPr/>
-        </p:nvSpPr>
-        <p:spPr>
-          <a:xfrm>
-            <a:off x="457200" y="4663440"/>
-            <a:ext cx="7315200" cy="365760"/>
-          </a:xfrm>
-          <a:prstGeom prst="rect">
-            <a:avLst/>
-          </a:prstGeom>
-          <a:noFill/>
-          <a:ln/>
-        </p:spPr>
-        <p:txBody>
-          <a:bodyPr wrap="square" lIns="0" tIns="0" rIns="0" bIns="0" rtlCol="0" anchor="ctr"/>
-          <a:lstStyle/>
-          <a:p>
-            <a:pPr indent="0" marL="0">
-              <a:buNone/>
-            </a:pPr>
-            <a:r>
-              <a:rPr lang="en-US" sz="1800" b="1" dirty="0">
-                <a:solidFill>
-                  <a:srgbClr val="1F3B7A"/>
-                </a:solidFill>
-              </a:rPr>
-              <a:t>Usulan langkah berikutnya</a:t>
-            </a:r>
-            <a:endParaRPr lang="en-US" sz="1800" dirty="0"/>
-          </a:p>
-        </p:txBody>
-      </p:sp>
-      <p:sp>
-        <p:nvSpPr>
-          <p:cNvPr id="24" name="Siapkan akun dan level approval"/>
+              <a:spcAft>
+                <a:spcPts val="600"/>
+              </a:spcAft>
+              <a:buNone/>
+            </a:pPr>
+            <a:r>
+              <a:rPr lang="en-US" sz="2000" b="1" dirty="0">
+                <a:solidFill>
+                  <a:srgbClr val="FFFFFF"/>
+                </a:solidFill>
+              </a:rPr>
+              <a:t>Otomatis ke SAP</a:t>
+            </a:r>
+            <a:endParaRPr lang="en-US" sz="2000" dirty="0"/>
+          </a:p>
+          <a:p>
+            <a:pPr indent="0" marL="0">
+              <a:spcAft>
+                <a:spcPts val="600"/>
+              </a:spcAft>
+              <a:buNone/>
+            </a:pPr>
+            <a:r>
+              <a:rPr lang="en-US" sz="1400" dirty="0">
+                <a:solidFill>
+                  <a:srgbClr val="CADCFC"/>
+                </a:solidFill>
+              </a:rPr>
+              <a:t>Sales Order, PUR, PO, GRPO, Inventory Transfer, dan DO dibuat setelah disetujui, tanpa input ulang.</a:t>
+            </a:r>
+            <a:endParaRPr lang="en-US" sz="2000" dirty="0"/>
+          </a:p>
+        </p:txBody>
+      </p:sp>
+      <p:sp>
+        <p:nvSpPr>
+          <p:cNvPr id="9" name="Terlacak dan terkendali"/>
           <p:cNvSpPr/>
           <p:nvPr/>
         </p:nvSpPr>
         <p:spPr>
           <a:xfrm>
-            <a:off x="457200" y="5120640"/>
-            <a:ext cx="3611880" cy="1051560"/>
+            <a:off x="8046720" y="1325880"/>
+            <a:ext cx="3611880" cy="2514600"/>
           </a:xfrm>
           <a:prstGeom prst="roundRect">
             <a:avLst>
-              <a:gd name="adj" fmla="val 10435"/>
+              <a:gd name="adj" fmla="val 4364"/>
             </a:avLst>
           </a:prstGeom>
           <a:solidFill>
-            <a:srgbClr val="1F3B7A"/>
+            <a:srgbClr val="2A4A8F"/>
           </a:solidFill>
           <a:ln w="12700">
             <a:solidFill>
-              <a:srgbClr val="1F3B7A"/>
+              <a:srgbClr val="2A4A8F"/>
             </a:solidFill>
             <a:prstDash val="solid"/>
           </a:ln>
@@ -4684,14 +4215,14 @@
       </p:sp>
       <p:sp>
         <p:nvSpPr>
-          <p:cNvPr id="25" name="Text 23"/>
+          <p:cNvPr id="10" name="Text 8"/>
           <p:cNvSpPr txBox="1"/>
           <p:nvPr/>
         </p:nvSpPr>
         <p:spPr>
           <a:xfrm>
-            <a:off x="640080" y="5193792"/>
-            <a:ext cx="457200" cy="868680"/>
+            <a:off x="8321040" y="1463040"/>
+            <a:ext cx="822960" cy="822960"/>
           </a:xfrm>
           <a:prstGeom prst="rect">
             <a:avLst/>
@@ -4707,27 +4238,27 @@
               <a:buNone/>
             </a:pPr>
             <a:r>
-              <a:rPr lang="en-US" sz="3200" b="1" dirty="0">
+              <a:rPr lang="en-US" sz="4800" b="1" dirty="0">
                 <a:solidFill>
                   <a:srgbClr val="FF6B1A"/>
                 </a:solidFill>
               </a:rPr>
-              <a:t>1</a:t>
-            </a:r>
-            <a:endParaRPr lang="en-US" sz="3200" dirty="0"/>
-          </a:p>
-        </p:txBody>
-      </p:sp>
-      <p:sp>
-        <p:nvSpPr>
-          <p:cNvPr id="26" name="Text 24"/>
+              <a:t>3</a:t>
+            </a:r>
+            <a:endParaRPr lang="en-US" sz="4800" dirty="0"/>
+          </a:p>
+        </p:txBody>
+      </p:sp>
+      <p:sp>
+        <p:nvSpPr>
+          <p:cNvPr id="11" name="Text 9"/>
           <p:cNvSpPr txBox="1"/>
           <p:nvPr/>
         </p:nvSpPr>
         <p:spPr>
           <a:xfrm>
-            <a:off x="1143000" y="5193792"/>
-            <a:ext cx="2788920" cy="868680"/>
+            <a:off x="8321040" y="2331720"/>
+            <a:ext cx="3108960" cy="1417320"/>
           </a:xfrm>
           <a:prstGeom prst="rect">
             <a:avLst/>
@@ -4736,60 +4267,66 @@
           <a:ln/>
         </p:spPr>
         <p:txBody>
-          <a:bodyPr wrap="square" lIns="0" tIns="0" rIns="0" bIns="0" rtlCol="0" anchor="ctr"/>
-          <a:lstStyle/>
-          <a:p>
-            <a:pPr indent="0" marL="0">
-              <a:buNone/>
-            </a:pPr>
-            <a:r>
-              <a:rPr lang="en-US" sz="1500" b="1" dirty="0">
+          <a:bodyPr wrap="square" lIns="0" tIns="0" rIns="0" bIns="0" rtlCol="0" anchor="t"/>
+          <a:lstStyle/>
+          <a:p>
+            <a:pPr indent="0" marL="0">
+              <a:spcAft>
+                <a:spcPts val="600"/>
+              </a:spcAft>
+              <a:buNone/>
+            </a:pPr>
+            <a:r>
+              <a:rPr lang="en-US" sz="2000" b="1" dirty="0">
                 <a:solidFill>
                   <a:srgbClr val="FFFFFF"/>
                 </a:solidFill>
               </a:rPr>
-              <a:t>Siapkan akun dan level approval</a:t>
-            </a:r>
-            <a:endParaRPr lang="en-US" sz="1500" dirty="0"/>
-          </a:p>
-          <a:p>
-            <a:pPr indent="0" marL="0">
-              <a:buNone/>
-            </a:pPr>
-            <a:r>
-              <a:rPr lang="en-US" sz="1200" dirty="0">
+              <a:t>Terlacak dan terkendali</a:t>
+            </a:r>
+            <a:endParaRPr lang="en-US" sz="2000" dirty="0"/>
+          </a:p>
+          <a:p>
+            <a:pPr indent="0" marL="0">
+              <a:spcAft>
+                <a:spcPts val="600"/>
+              </a:spcAft>
+              <a:buNone/>
+            </a:pPr>
+            <a:r>
+              <a:rPr lang="en-US" sz="1400" dirty="0">
                 <a:solidFill>
                   <a:srgbClr val="CADCFC"/>
                 </a:solidFill>
               </a:rPr>
-              <a:t>untuk setiap peran dan kapal</a:t>
-            </a:r>
-            <a:endParaRPr lang="en-US" sz="1500" dirty="0"/>
-          </a:p>
-        </p:txBody>
-      </p:sp>
-      <p:sp>
-        <p:nvSpPr>
-          <p:cNvPr id="27" name="Pilot di satu kapal (KM Awu)"/>
+              <a:t>Setiap permintaan terpantau per tahap, dan setiap persetujuan tercatat berjenjang.</a:t>
+            </a:r>
+            <a:endParaRPr lang="en-US" sz="2000" dirty="0"/>
+          </a:p>
+        </p:txBody>
+      </p:sp>
+      <p:sp>
+        <p:nvSpPr>
+          <p:cNvPr id="12" name="Dukungan direksi"/>
           <p:cNvSpPr/>
           <p:nvPr/>
         </p:nvSpPr>
         <p:spPr>
           <a:xfrm>
-            <a:off x="4251960" y="5120640"/>
-            <a:ext cx="3611880" cy="1051560"/>
+            <a:off x="457200" y="4114800"/>
+            <a:ext cx="7863840" cy="2011680"/>
           </a:xfrm>
           <a:prstGeom prst="roundRect">
             <a:avLst>
-              <a:gd name="adj" fmla="val 10435"/>
+              <a:gd name="adj" fmla="val 5455"/>
             </a:avLst>
           </a:prstGeom>
           <a:solidFill>
-            <a:srgbClr val="1F3B7A"/>
+            <a:srgbClr val="FFFFFF"/>
           </a:solidFill>
           <a:ln w="12700">
             <a:solidFill>
-              <a:srgbClr val="1F3B7A"/>
+              <a:srgbClr val="FFFFFF"/>
             </a:solidFill>
             <a:prstDash val="solid"/>
           </a:ln>
@@ -4797,14 +4334,14 @@
       </p:sp>
       <p:sp>
         <p:nvSpPr>
-          <p:cNvPr id="28" name="Text 26"/>
+          <p:cNvPr id="13" name="Text 11"/>
           <p:cNvSpPr txBox="1"/>
           <p:nvPr/>
         </p:nvSpPr>
         <p:spPr>
           <a:xfrm>
-            <a:off x="4434840" y="5193792"/>
-            <a:ext cx="457200" cy="868680"/>
+            <a:off x="731520" y="4251960"/>
+            <a:ext cx="7315200" cy="411480"/>
           </a:xfrm>
           <a:prstGeom prst="rect">
             <a:avLst/>
@@ -4820,27 +4357,27 @@
               <a:buNone/>
             </a:pPr>
             <a:r>
-              <a:rPr lang="en-US" sz="3200" b="1" dirty="0">
-                <a:solidFill>
-                  <a:srgbClr val="FF6B1A"/>
-                </a:solidFill>
-              </a:rPr>
-              <a:t>2</a:t>
-            </a:r>
-            <a:endParaRPr lang="en-US" sz="3200" dirty="0"/>
-          </a:p>
-        </p:txBody>
-      </p:sp>
-      <p:sp>
-        <p:nvSpPr>
-          <p:cNvPr id="29" name="Text 27"/>
+              <a:rPr lang="en-US" sz="1800" b="1" dirty="0">
+                <a:solidFill>
+                  <a:srgbClr val="1F3B7A"/>
+                </a:solidFill>
+              </a:rPr>
+              <a:t>Dukungan yang dimohonkan dari Direksi</a:t>
+            </a:r>
+            <a:endParaRPr lang="en-US" sz="1800" dirty="0"/>
+          </a:p>
+        </p:txBody>
+      </p:sp>
+      <p:sp>
+        <p:nvSpPr>
+          <p:cNvPr id="14" name="Text 12"/>
           <p:cNvSpPr txBox="1"/>
           <p:nvPr/>
         </p:nvSpPr>
         <p:spPr>
           <a:xfrm>
-            <a:off x="4937760" y="5193792"/>
-            <a:ext cx="2788920" cy="868680"/>
+            <a:off x="731520" y="4754880"/>
+            <a:ext cx="7315200" cy="1234440"/>
           </a:xfrm>
           <a:prstGeom prst="rect">
             <a:avLst/>
@@ -4849,33 +4386,43 @@
           <a:ln/>
         </p:spPr>
         <p:txBody>
-          <a:bodyPr wrap="square" lIns="0" tIns="0" rIns="0" bIns="0" rtlCol="0" anchor="ctr"/>
-          <a:lstStyle/>
-          <a:p>
-            <a:pPr indent="0" marL="0">
-              <a:buNone/>
-            </a:pPr>
-            <a:r>
-              <a:rPr lang="en-US" sz="1500" b="1" dirty="0">
-                <a:solidFill>
-                  <a:srgbClr val="FFFFFF"/>
-                </a:solidFill>
-              </a:rPr>
-              <a:t>Pilot di satu kapal (KM Awu)</a:t>
+          <a:bodyPr wrap="square" lIns="0" tIns="0" rIns="0" bIns="0" rtlCol="0" anchor="t"/>
+          <a:lstStyle/>
+          <a:p>
+            <a:pPr marL="342900" indent="-342900">
+              <a:spcAft>
+                <a:spcPts val="800"/>
+              </a:spcAft>
+              <a:buSzPct val="100000"/>
+              <a:buFont typeface="+mj-lt"/>
+              <a:buAutoNum type="arabicPeriod" startAt="1"/>
+            </a:pPr>
+            <a:r>
+              <a:rPr lang="en-US" sz="1500" dirty="0">
+                <a:solidFill>
+                  <a:srgbClr val="1B2437"/>
+                </a:solidFill>
+              </a:rPr>
+              <a:t>Persetujuan penerapan PID POS di toko kapal, DC, dan kantor pusat.</a:t>
             </a:r>
             <a:endParaRPr lang="en-US" sz="1500" dirty="0"/>
           </a:p>
           <a:p>
-            <a:pPr indent="0" marL="0">
-              <a:buNone/>
-            </a:pPr>
-            <a:r>
-              <a:rPr lang="en-US" sz="1200" dirty="0">
-                <a:solidFill>
-                  <a:srgbClr val="CADCFC"/>
-                </a:solidFill>
-              </a:rPr>
-              <a:t>dengan SAP produksi</a:t>
+            <a:pPr marL="342900" indent="-342900">
+              <a:spcAft>
+                <a:spcPts val="800"/>
+              </a:spcAft>
+              <a:buSzPct val="100000"/>
+              <a:buFont typeface="+mj-lt"/>
+              <a:buAutoNum type="arabicPeriod" startAt="1"/>
+            </a:pPr>
+            <a:r>
+              <a:rPr lang="en-US" sz="1500" dirty="0">
+                <a:solidFill>
+                  <a:srgbClr val="1B2437"/>
+                </a:solidFill>
+              </a:rPr>
+              <a:t>Arahan kepada unit terkait untuk menjalankan permintaan barang dan penjualan melalui PID POS.</a:t>
             </a:r>
             <a:endParaRPr lang="en-US" sz="1500" dirty="0"/>
           </a:p>
@@ -4883,41 +4430,65 @@
       </p:sp>
       <p:sp>
         <p:nvSpPr>
-          <p:cNvPr id="30" name="Sosialisasi ke seluruh peran"/>
+          <p:cNvPr id="15" name="Kartu logo"/>
           <p:cNvSpPr/>
           <p:nvPr/>
         </p:nvSpPr>
         <p:spPr>
           <a:xfrm>
-            <a:off x="8046720" y="5120640"/>
-            <a:ext cx="3611880" cy="1051560"/>
+            <a:off x="8595360" y="4114800"/>
+            <a:ext cx="3136392" cy="2011680"/>
           </a:xfrm>
           <a:prstGeom prst="roundRect">
             <a:avLst>
-              <a:gd name="adj" fmla="val 10435"/>
+              <a:gd name="adj" fmla="val 5455"/>
             </a:avLst>
           </a:prstGeom>
           <a:solidFill>
-            <a:srgbClr val="1F3B7A"/>
+            <a:srgbClr val="FFFFFF"/>
           </a:solidFill>
           <a:ln w="12700">
             <a:solidFill>
-              <a:srgbClr val="1F3B7A"/>
+              <a:srgbClr val="FFFFFF"/>
             </a:solidFill>
             <a:prstDash val="solid"/>
           </a:ln>
         </p:spPr>
       </p:sp>
-      <p:sp>
-        <p:nvSpPr>
-          <p:cNvPr id="31" name="Text 29"/>
+      <p:pic>
+        <p:nvPicPr>
+          <p:cNvPr id="16" name="Logo" descr="Logo PELNI Services">    </p:cNvPr>
+          <p:cNvPicPr>
+            <a:picLocks noChangeAspect="1"/>
+          </p:cNvPicPr>
+          <p:nvPr/>
+        </p:nvPicPr>
+        <p:blipFill>
+          <a:blip r:embed="rId1"/>
+          <a:stretch>
+            <a:fillRect/>
+          </a:stretch>
+        </p:blipFill>
+        <p:spPr>
+          <a:xfrm>
+            <a:off x="8915400" y="4297680"/>
+            <a:ext cx="2496312" cy="1143000"/>
+          </a:xfrm>
+          <a:prstGeom prst="rect">
+            <a:avLst/>
+          </a:prstGeom>
+        </p:spPr>
+      </p:pic>
+      <p:sp>
+        <p:nvSpPr>
+          <p:cNvPr id="17" name="Text 14"/>
           <p:cNvSpPr txBox="1"/>
           <p:nvPr/>
         </p:nvSpPr>
         <p:spPr>
           <a:xfrm>
-            <a:off x="8229600" y="5193792"/>
-            <a:ext cx="457200" cy="868680"/>
+            <a:off x="8595360" y="5486400"/>
+            <a:ext cx="3136392" cy="457200"/>
           </a:xfrm>
           <a:prstGeom prst="rect">
             <a:avLst/>
@@ -4929,68 +4500,18 @@
           <a:bodyPr wrap="square" lIns="0" tIns="0" rIns="0" bIns="0" rtlCol="0" anchor="ctr"/>
           <a:lstStyle/>
           <a:p>
-            <a:pPr indent="0" marL="0">
-              <a:buNone/>
-            </a:pPr>
-            <a:r>
-              <a:rPr lang="en-US" sz="3200" b="1" dirty="0">
-                <a:solidFill>
-                  <a:srgbClr val="FF6B1A"/>
-                </a:solidFill>
-              </a:rPr>
-              <a:t>3</a:t>
-            </a:r>
-            <a:endParaRPr lang="en-US" sz="3200" dirty="0"/>
-          </a:p>
-        </p:txBody>
-      </p:sp>
-      <p:sp>
-        <p:nvSpPr>
-          <p:cNvPr id="32" name="Text 30"/>
-          <p:cNvSpPr txBox="1"/>
-          <p:nvPr/>
-        </p:nvSpPr>
-        <p:spPr>
-          <a:xfrm>
-            <a:off x="8732520" y="5193792"/>
-            <a:ext cx="2788920" cy="868680"/>
-          </a:xfrm>
-          <a:prstGeom prst="rect">
-            <a:avLst/>
-          </a:prstGeom>
-          <a:noFill/>
-          <a:ln/>
-        </p:spPr>
-        <p:txBody>
-          <a:bodyPr wrap="square" lIns="0" tIns="0" rIns="0" bIns="0" rtlCol="0" anchor="ctr"/>
-          <a:lstStyle/>
-          <a:p>
-            <a:pPr indent="0" marL="0">
-              <a:buNone/>
-            </a:pPr>
-            <a:r>
-              <a:rPr lang="en-US" sz="1500" b="1" dirty="0">
-                <a:solidFill>
-                  <a:srgbClr val="FFFFFF"/>
-                </a:solidFill>
-              </a:rPr>
-              <a:t>Sosialisasi ke seluruh peran</a:t>
-            </a:r>
-            <a:endParaRPr lang="en-US" sz="1500" dirty="0"/>
-          </a:p>
-          <a:p>
-            <a:pPr indent="0" marL="0">
-              <a:buNone/>
-            </a:pPr>
-            <a:r>
-              <a:rPr lang="en-US" sz="1200" dirty="0">
-                <a:solidFill>
-                  <a:srgbClr val="CADCFC"/>
-                </a:solidFill>
-              </a:rPr>
-              <a:t>memakai manual dan video</a:t>
-            </a:r>
-            <a:endParaRPr lang="en-US" sz="1500" dirty="0"/>
+            <a:pPr algn="ctr" indent="0" marL="0">
+              <a:buNone/>
+            </a:pPr>
+            <a:r>
+              <a:rPr lang="en-US" sz="2000" b="1" dirty="0">
+                <a:solidFill>
+                  <a:srgbClr val="1F3B7A"/>
+                </a:solidFill>
+              </a:rPr>
+              <a:t>Terima kasih</a:t>
+            </a:r>
+            <a:endParaRPr lang="en-US" sz="2000" dirty="0"/>
           </a:p>
         </p:txBody>
       </p:sp>
@@ -5024,7 +4545,7 @@
             <a:lvl1pPr>
               <a:defRPr sz="1000">
                 <a:solidFill>
-                  <a:srgbClr val="5B6B86"/>
+                  <a:srgbClr val="CADCFC"/>
                 </a:solidFill>
               </a:defRPr>
             </a:lvl1pPr>

</xml_diff>